<commit_message>
docs: update presentation to match the current system
</commit_message>
<xml_diff>
--- a/Agentic_Debate_Arena.pptx
+++ b/Agentic_Debate_Arena.pptx
@@ -2465,7 +2465,7 @@
       </p:sp>
       <p:pic>
         <p:nvPicPr>
-          <p:cNvPr id="3" name="Image 0" descr="Verdict report screenshot of a six-turn debate">    </p:cNvPr>
+          <p:cNvPr id="3" name="Image 0" descr="Verdict report of a ten-turn debate on gaming versus business laptops">    </p:cNvPr>
           <p:cNvPicPr>
             <a:picLocks noChangeAspect="1"/>
           </p:cNvPicPr>
@@ -2559,7 +2559,7 @@
                 <a:ea typeface="Calibri" pitchFamily="34" charset="-122"/>
                 <a:cs typeface="Calibri" pitchFamily="34" charset="-120"/>
               </a:rPr>
-              <a:t>6-turn debate on skills vs. academics ends in a Draw with 0 contradictions.</a:t>
+              <a:t>10-turn debate on gaming vs. business laptops: Agent A wins 2–0 on proven refutations.</a:t>
             </a:r>
             <a:endParaRPr lang="en-US" sz="1400" dirty="0"/>
           </a:p>
@@ -2637,7 +2637,7 @@
                 <a:ea typeface="Calibri" pitchFamily="34" charset="-122"/>
                 <a:cs typeface="Calibri" pitchFamily="34" charset="-120"/>
               </a:rPr>
-              <a:t>We used MCTS with UCB1 and CNF resolution to get grounded, contradiction-checked debates, with the LLM only phrasing claims.</a:t>
+              <a:t>MCTS with resolution rollouts chooses each argument and CNF resolution proves every refutation; the LLM only proposes and phrases.</a:t>
             </a:r>
             <a:endParaRPr lang="en-US" sz="1400" dirty="0"/>
           </a:p>
@@ -2957,7 +2957,7 @@
                 <a:ea typeface="Calibri" pitchFamily="34" charset="-122"/>
                 <a:cs typeface="Calibri" pitchFamily="34" charset="-120"/>
               </a:rPr>
-              <a:t>More simulations with real rollouts and a learned value function.</a:t>
+              <a:t>Multi-step rollouts between both agents and a learned value function.</a:t>
             </a:r>
             <a:endParaRPr lang="en-US" sz="1400" dirty="0"/>
           </a:p>
@@ -3525,7 +3525,7 @@
                 <a:ea typeface="Calibri" pitchFamily="34" charset="-122"/>
                 <a:cs typeface="Calibri" pitchFamily="34" charset="-120"/>
               </a:rPr>
-              <a:t>Online debate and AI-assisted argumentation increasingly shape how people form opinions. Large language models now write fluent arguments on any topic, but fluency is not the same as logical soundness. Traditional debate systems let a single LLM write, judge and fact-check its own arguments. They choose rebuttals by prompting rather than by search. They cannot prove when an argument contradicts itself, so invented facts and repeated points pass unchecked. The proposed Agentic Debate Arena pairs two agents that select each rebuttal with Monte Carlo Tree Search (UCB1) and verify logical consistency with CNF propositional resolution. The LLM only phrases the chosen claim over a fixed 20-fact base, so every argument is grounded and every contradiction is formally proved. The system is evaluated on contradictions forced, contradictions received, unique-claim coverage and the resulting heuristic score. A 6-turn demo debate ends in a Draw with 0 contradictions, and the implementation passes 231+ automated tests.</a:t>
+              <a:t>Online debate and AI-assisted argumentation increasingly shape how people form opinions. Large language models now write fluent arguments on any topic, but fluency is not the same as logical soundness. Traditional debate systems let a single LLM write, judge and fact-check its own arguments. They choose rebuttals by prompting rather than by search, and they cannot prove when an argument contradicts itself. The proposed Agentic Debate Arena frames each topic as two explicit positions and grounds the debate in a generated fact base. On every turn the LLM proposes candidate arguments, Monte Carlo Tree Search (UCB1) chooses one through resolution-based simulations, and CNF propositional resolution proves each refutation and self-contradiction. The verdict is the net count of proven refutations. In a 10-turn case study on gaming versus business laptops, Agent A won 2–0, and the implementation passes 223 automated tests.</a:t>
             </a:r>
             <a:endParaRPr lang="en-US" sz="1500" dirty="0"/>
           </a:p>
@@ -6239,7 +6239,7 @@
                 <a:ea typeface="Calibri" pitchFamily="34" charset="-122"/>
                 <a:cs typeface="Calibri" pitchFamily="34" charset="-120"/>
               </a:rPr>
-              <a:t>Select each rebuttal with MCTS (UCB1, 10 simulations over 3–5 candidates)</a:t>
+              <a:t>Choose each argument with MCTS (UCB1, 32 resolution-scored simulations)</a:t>
             </a:r>
             <a:endParaRPr lang="en-US" sz="1400" dirty="0"/>
           </a:p>
@@ -6573,7 +6573,7 @@
                 <a:ea typeface="Calibri" pitchFamily="34" charset="-122"/>
                 <a:cs typeface="Calibri" pitchFamily="34" charset="-120"/>
               </a:rPr>
-              <a:t>Limit the LLM to phrasing the chosen claim in natural language</a:t>
+              <a:t>Let the LLM only propose and phrase candidates; MCTS decides</a:t>
             </a:r>
             <a:endParaRPr lang="en-US" sz="1400" dirty="0"/>
           </a:p>
@@ -6709,8 +6709,8 @@
         </p:blipFill>
         <p:spPr>
           <a:xfrm>
-            <a:off x="1345861" y="1097280"/>
-            <a:ext cx="6452279" cy="3886200"/>
+            <a:off x="1811259" y="1097280"/>
+            <a:ext cx="5521482" cy="3886200"/>
           </a:xfrm>
           <a:prstGeom prst="rect">
             <a:avLst/>
@@ -7123,7 +7123,7 @@
                 <a:ea typeface="Calibri" pitchFamily="34" charset="-122"/>
                 <a:cs typeface="Calibri" pitchFamily="34" charset="-120"/>
               </a:rPr>
-              <a:t>Simulation scored by H(s)</a:t>
+              <a:t>Simulation by resolution rollout</a:t>
             </a:r>
             <a:endParaRPr lang="en-US" sz="1400" dirty="0"/>
           </a:p>
@@ -7918,7 +7918,7 @@
                 <a:ea typeface="Calibri" pitchFamily="34" charset="-122"/>
                 <a:cs typeface="Calibri" pitchFamily="34" charset="-120"/>
               </a:rPr>
-              <a:t>LLM inference on Groq LPU and NVIDIA NIM</a:t>
+              <a:t>LLMs via Groq, OpenRouter, Gemini, NVIDIA NIM</a:t>
             </a:r>
             <a:endParaRPr lang="en-US" sz="1400" dirty="0"/>
           </a:p>
@@ -8130,7 +8130,7 @@
                 <a:ea typeface="Calibri" pitchFamily="34" charset="-122"/>
                 <a:cs typeface="Calibri" pitchFamily="34" charset="-120"/>
               </a:rPr>
-              <a:t>Gemini and OpenAI SDKs</a:t>
+              <a:t>Google GenAI and OpenAI SDKs</a:t>
             </a:r>
             <a:endParaRPr lang="en-US" sz="1400" dirty="0"/>
           </a:p>
@@ -8279,7 +8279,7 @@
                 <a:ea typeface="Calibri" pitchFamily="34" charset="-122"/>
                 <a:cs typeface="Calibri" pitchFamily="34" charset="-120"/>
               </a:rPr>
-              <a:t>10 MCTS simulations per turn</a:t>
+              <a:t>32 MCTS simulations per turn</a:t>
             </a:r>
             <a:endParaRPr lang="en-US" sz="1400" dirty="0"/>
           </a:p>
@@ -8300,7 +8300,7 @@
                 <a:ea typeface="Calibri" pitchFamily="34" charset="-122"/>
                 <a:cs typeface="Calibri" pitchFamily="34" charset="-120"/>
               </a:rPr>
-              <a:t>3–5 candidate moves per turn</a:t>
+              <a:t>~4 LLM-proposed candidates per turn</a:t>
             </a:r>
             <a:endParaRPr lang="en-US" sz="1400" dirty="0"/>
           </a:p>
@@ -8342,7 +8342,7 @@
                 <a:ea typeface="Calibri" pitchFamily="34" charset="-122"/>
                 <a:cs typeface="Calibri" pitchFamily="34" charset="-120"/>
               </a:rPr>
-              <a:t>231+ tests in 13 files</a:t>
+              <a:t>223 tests in 12 files</a:t>
             </a:r>
             <a:endParaRPr lang="en-US" sz="1400" dirty="0"/>
           </a:p>

</xml_diff>